<commit_message>
[pe] fix problems with themes
</commit_message>
<xml_diff>
--- a/slide/themes/src/12_agreement.pptx
+++ b/slide/themes/src/12_agreement.pptx
@@ -736,9 +736,6 @@
                     <a:lumOff val="25000"/>
                   </a:schemeClr>
                 </a:solidFill>
-                <a:latin typeface="Verdana"/>
-                <a:ea typeface="Verdana"/>
-                <a:cs typeface="Verdana"/>
               </a:defRPr>
             </a:lvl1pPr>
             <a:lvl2pPr>
@@ -749,9 +746,6 @@
                     <a:lumOff val="25000"/>
                   </a:schemeClr>
                 </a:solidFill>
-                <a:latin typeface="Verdana"/>
-                <a:ea typeface="Verdana"/>
-                <a:cs typeface="Verdana"/>
               </a:defRPr>
             </a:lvl2pPr>
             <a:lvl3pPr>
@@ -762,9 +756,6 @@
                     <a:lumOff val="25000"/>
                   </a:schemeClr>
                 </a:solidFill>
-                <a:latin typeface="Verdana"/>
-                <a:ea typeface="Verdana"/>
-                <a:cs typeface="Verdana"/>
               </a:defRPr>
             </a:lvl3pPr>
             <a:lvl4pPr>
@@ -775,9 +766,6 @@
                     <a:lumOff val="25000"/>
                   </a:schemeClr>
                 </a:solidFill>
-                <a:latin typeface="Verdana"/>
-                <a:ea typeface="Verdana"/>
-                <a:cs typeface="Verdana"/>
               </a:defRPr>
             </a:lvl4pPr>
             <a:lvl5pPr>
@@ -788,9 +776,6 @@
                     <a:lumOff val="25000"/>
                   </a:schemeClr>
                 </a:solidFill>
-                <a:latin typeface="Verdana"/>
-                <a:ea typeface="Verdana"/>
-                <a:cs typeface="Verdana"/>
               </a:defRPr>
             </a:lvl5pPr>
             <a:lvl6pPr>
@@ -801,9 +786,6 @@
                     <a:lumOff val="25000"/>
                   </a:schemeClr>
                 </a:solidFill>
-                <a:latin typeface="Verdana"/>
-                <a:ea typeface="Verdana"/>
-                <a:cs typeface="Verdana"/>
               </a:defRPr>
             </a:lvl6pPr>
             <a:lvl7pPr>
@@ -814,9 +796,6 @@
                     <a:lumOff val="25000"/>
                   </a:schemeClr>
                 </a:solidFill>
-                <a:latin typeface="Verdana"/>
-                <a:ea typeface="Verdana"/>
-                <a:cs typeface="Verdana"/>
               </a:defRPr>
             </a:lvl7pPr>
             <a:lvl8pPr>
@@ -827,9 +806,6 @@
                     <a:lumOff val="25000"/>
                   </a:schemeClr>
                 </a:solidFill>
-                <a:latin typeface="Verdana"/>
-                <a:ea typeface="Verdana"/>
-                <a:cs typeface="Verdana"/>
               </a:defRPr>
             </a:lvl8pPr>
             <a:lvl9pPr>
@@ -840,9 +816,6 @@
                     <a:lumOff val="25000"/>
                   </a:schemeClr>
                 </a:solidFill>
-                <a:latin typeface="Verdana"/>
-                <a:ea typeface="Verdana"/>
-                <a:cs typeface="Verdana"/>
               </a:defRPr>
             </a:lvl9pPr>
           </a:lstStyle>
@@ -886,9 +859,6 @@
                     <a:lumOff val="25000"/>
                   </a:schemeClr>
                 </a:solidFill>
-                <a:latin typeface="Verdana"/>
-                <a:ea typeface="Verdana"/>
-                <a:cs typeface="Verdana"/>
               </a:defRPr>
             </a:lvl1pPr>
             <a:lvl2pPr marL="457200" indent="0" algn="ctr">
@@ -900,9 +870,6 @@
                     <a:lumOff val="25000"/>
                   </a:schemeClr>
                 </a:solidFill>
-                <a:latin typeface="Verdana"/>
-                <a:ea typeface="Verdana"/>
-                <a:cs typeface="Verdana"/>
               </a:defRPr>
             </a:lvl2pPr>
             <a:lvl3pPr marL="914400" indent="0" algn="ctr">
@@ -914,9 +881,6 @@
                     <a:lumOff val="25000"/>
                   </a:schemeClr>
                 </a:solidFill>
-                <a:latin typeface="Verdana"/>
-                <a:ea typeface="Verdana"/>
-                <a:cs typeface="Verdana"/>
               </a:defRPr>
             </a:lvl3pPr>
             <a:lvl4pPr marL="1371600" indent="0" algn="ctr">
@@ -928,9 +892,6 @@
                     <a:lumOff val="25000"/>
                   </a:schemeClr>
                 </a:solidFill>
-                <a:latin typeface="Verdana"/>
-                <a:ea typeface="Verdana"/>
-                <a:cs typeface="Verdana"/>
               </a:defRPr>
             </a:lvl4pPr>
             <a:lvl5pPr marL="1828800" indent="0" algn="ctr">
@@ -942,9 +903,6 @@
                     <a:lumOff val="25000"/>
                   </a:schemeClr>
                 </a:solidFill>
-                <a:latin typeface="Verdana"/>
-                <a:ea typeface="Verdana"/>
-                <a:cs typeface="Verdana"/>
               </a:defRPr>
             </a:lvl5pPr>
             <a:lvl6pPr marL="2286000" indent="0" algn="ctr">
@@ -956,9 +914,6 @@
                     <a:lumOff val="25000"/>
                   </a:schemeClr>
                 </a:solidFill>
-                <a:latin typeface="Verdana"/>
-                <a:ea typeface="Verdana"/>
-                <a:cs typeface="Verdana"/>
               </a:defRPr>
             </a:lvl6pPr>
             <a:lvl7pPr marL="2743200" indent="0" algn="ctr">
@@ -970,9 +925,6 @@
                     <a:lumOff val="25000"/>
                   </a:schemeClr>
                 </a:solidFill>
-                <a:latin typeface="Verdana"/>
-                <a:ea typeface="Verdana"/>
-                <a:cs typeface="Verdana"/>
               </a:defRPr>
             </a:lvl7pPr>
             <a:lvl8pPr marL="3200400" indent="0" algn="ctr">
@@ -984,9 +936,6 @@
                     <a:lumOff val="25000"/>
                   </a:schemeClr>
                 </a:solidFill>
-                <a:latin typeface="Verdana"/>
-                <a:ea typeface="Verdana"/>
-                <a:cs typeface="Verdana"/>
               </a:defRPr>
             </a:lvl8pPr>
             <a:lvl9pPr marL="3657600" indent="0" algn="ctr">
@@ -998,9 +947,6 @@
                     <a:lumOff val="25000"/>
                   </a:schemeClr>
                 </a:solidFill>
-                <a:latin typeface="Verdana"/>
-                <a:ea typeface="Verdana"/>
-                <a:cs typeface="Verdana"/>
               </a:defRPr>
             </a:lvl9pPr>
           </a:lstStyle>
@@ -4109,9 +4055,6 @@
                     <a:lumOff val="25000"/>
                   </a:schemeClr>
                 </a:solidFill>
-                <a:latin typeface="Verdana"/>
-                <a:ea typeface="Verdana"/>
-                <a:cs typeface="Verdana"/>
               </a:defRPr>
             </a:lvl1pPr>
             <a:lvl2pPr>
@@ -4122,9 +4065,6 @@
                     <a:lumOff val="25000"/>
                   </a:schemeClr>
                 </a:solidFill>
-                <a:latin typeface="Verdana"/>
-                <a:ea typeface="Verdana"/>
-                <a:cs typeface="Verdana"/>
               </a:defRPr>
             </a:lvl2pPr>
             <a:lvl3pPr>
@@ -4135,9 +4075,6 @@
                     <a:lumOff val="25000"/>
                   </a:schemeClr>
                 </a:solidFill>
-                <a:latin typeface="Verdana"/>
-                <a:ea typeface="Verdana"/>
-                <a:cs typeface="Verdana"/>
               </a:defRPr>
             </a:lvl3pPr>
             <a:lvl4pPr>
@@ -4148,9 +4085,6 @@
                     <a:lumOff val="25000"/>
                   </a:schemeClr>
                 </a:solidFill>
-                <a:latin typeface="Verdana"/>
-                <a:ea typeface="Verdana"/>
-                <a:cs typeface="Verdana"/>
               </a:defRPr>
             </a:lvl4pPr>
             <a:lvl5pPr>
@@ -4161,9 +4095,6 @@
                     <a:lumOff val="25000"/>
                   </a:schemeClr>
                 </a:solidFill>
-                <a:latin typeface="Verdana"/>
-                <a:ea typeface="Verdana"/>
-                <a:cs typeface="Verdana"/>
               </a:defRPr>
             </a:lvl5pPr>
             <a:lvl6pPr>
@@ -4174,9 +4105,6 @@
                     <a:lumOff val="25000"/>
                   </a:schemeClr>
                 </a:solidFill>
-                <a:latin typeface="Verdana"/>
-                <a:ea typeface="Verdana"/>
-                <a:cs typeface="Verdana"/>
               </a:defRPr>
             </a:lvl6pPr>
             <a:lvl7pPr>
@@ -4187,9 +4115,6 @@
                     <a:lumOff val="25000"/>
                   </a:schemeClr>
                 </a:solidFill>
-                <a:latin typeface="Verdana"/>
-                <a:ea typeface="Verdana"/>
-                <a:cs typeface="Verdana"/>
               </a:defRPr>
             </a:lvl7pPr>
             <a:lvl8pPr>
@@ -4200,9 +4125,6 @@
                     <a:lumOff val="25000"/>
                   </a:schemeClr>
                 </a:solidFill>
-                <a:latin typeface="Verdana"/>
-                <a:ea typeface="Verdana"/>
-                <a:cs typeface="Verdana"/>
               </a:defRPr>
             </a:lvl8pPr>
             <a:lvl9pPr>
@@ -4213,9 +4135,6 @@
                     <a:lumOff val="25000"/>
                   </a:schemeClr>
                 </a:solidFill>
-                <a:latin typeface="Verdana"/>
-                <a:ea typeface="Verdana"/>
-                <a:cs typeface="Verdana"/>
               </a:defRPr>
             </a:lvl9pPr>
           </a:lstStyle>
@@ -4263,9 +4182,6 @@
                     <a:lumOff val="25000"/>
                   </a:schemeClr>
                 </a:solidFill>
-                <a:latin typeface="Verdana"/>
-                <a:ea typeface="Verdana"/>
-                <a:cs typeface="Verdana"/>
               </a:defRPr>
             </a:lvl1pPr>
             <a:lvl2pPr>
@@ -4276,9 +4192,6 @@
                     <a:lumOff val="25000"/>
                   </a:schemeClr>
                 </a:solidFill>
-                <a:latin typeface="Verdana"/>
-                <a:ea typeface="Verdana"/>
-                <a:cs typeface="Verdana"/>
               </a:defRPr>
             </a:lvl2pPr>
             <a:lvl3pPr>
@@ -4289,9 +4202,6 @@
                     <a:lumOff val="25000"/>
                   </a:schemeClr>
                 </a:solidFill>
-                <a:latin typeface="Verdana"/>
-                <a:ea typeface="Verdana"/>
-                <a:cs typeface="Verdana"/>
               </a:defRPr>
             </a:lvl3pPr>
             <a:lvl4pPr>
@@ -4302,9 +4212,6 @@
                     <a:lumOff val="25000"/>
                   </a:schemeClr>
                 </a:solidFill>
-                <a:latin typeface="Verdana"/>
-                <a:ea typeface="Verdana"/>
-                <a:cs typeface="Verdana"/>
               </a:defRPr>
             </a:lvl4pPr>
             <a:lvl5pPr>
@@ -4315,9 +4222,6 @@
                     <a:lumOff val="25000"/>
                   </a:schemeClr>
                 </a:solidFill>
-                <a:latin typeface="Verdana"/>
-                <a:ea typeface="Verdana"/>
-                <a:cs typeface="Verdana"/>
               </a:defRPr>
             </a:lvl5pPr>
             <a:lvl6pPr>
@@ -4328,9 +4232,6 @@
                     <a:lumOff val="25000"/>
                   </a:schemeClr>
                 </a:solidFill>
-                <a:latin typeface="Verdana"/>
-                <a:ea typeface="Verdana"/>
-                <a:cs typeface="Verdana"/>
               </a:defRPr>
             </a:lvl6pPr>
             <a:lvl7pPr>
@@ -4341,9 +4242,6 @@
                     <a:lumOff val="25000"/>
                   </a:schemeClr>
                 </a:solidFill>
-                <a:latin typeface="Verdana"/>
-                <a:ea typeface="Verdana"/>
-                <a:cs typeface="Verdana"/>
               </a:defRPr>
             </a:lvl7pPr>
             <a:lvl8pPr>
@@ -4354,9 +4252,6 @@
                     <a:lumOff val="25000"/>
                   </a:schemeClr>
                 </a:solidFill>
-                <a:latin typeface="Verdana"/>
-                <a:ea typeface="Verdana"/>
-                <a:cs typeface="Verdana"/>
               </a:defRPr>
             </a:lvl8pPr>
             <a:lvl9pPr>
@@ -4367,9 +4262,6 @@
                     <a:lumOff val="25000"/>
                   </a:schemeClr>
                 </a:solidFill>
-                <a:latin typeface="Verdana"/>
-                <a:ea typeface="Verdana"/>
-                <a:cs typeface="Verdana"/>
               </a:defRPr>
             </a:lvl9pPr>
           </a:lstStyle>
@@ -4896,9 +4788,6 @@
                     <a:lumOff val="25000"/>
                   </a:schemeClr>
                 </a:solidFill>
-                <a:latin typeface="Verdana"/>
-                <a:ea typeface="Verdana"/>
-                <a:cs typeface="Verdana"/>
               </a:defRPr>
             </a:lvl1pPr>
             <a:lvl2pPr>
@@ -4909,9 +4798,6 @@
                     <a:lumOff val="25000"/>
                   </a:schemeClr>
                 </a:solidFill>
-                <a:latin typeface="Verdana"/>
-                <a:ea typeface="Verdana"/>
-                <a:cs typeface="Verdana"/>
               </a:defRPr>
             </a:lvl2pPr>
             <a:lvl3pPr>
@@ -4922,9 +4808,6 @@
                     <a:lumOff val="25000"/>
                   </a:schemeClr>
                 </a:solidFill>
-                <a:latin typeface="Verdana"/>
-                <a:ea typeface="Verdana"/>
-                <a:cs typeface="Verdana"/>
               </a:defRPr>
             </a:lvl3pPr>
             <a:lvl4pPr>
@@ -4935,9 +4818,6 @@
                     <a:lumOff val="25000"/>
                   </a:schemeClr>
                 </a:solidFill>
-                <a:latin typeface="Verdana"/>
-                <a:ea typeface="Verdana"/>
-                <a:cs typeface="Verdana"/>
               </a:defRPr>
             </a:lvl4pPr>
             <a:lvl5pPr>
@@ -4948,9 +4828,6 @@
                     <a:lumOff val="25000"/>
                   </a:schemeClr>
                 </a:solidFill>
-                <a:latin typeface="Verdana"/>
-                <a:ea typeface="Verdana"/>
-                <a:cs typeface="Verdana"/>
               </a:defRPr>
             </a:lvl5pPr>
             <a:lvl6pPr>
@@ -4961,9 +4838,6 @@
                     <a:lumOff val="25000"/>
                   </a:schemeClr>
                 </a:solidFill>
-                <a:latin typeface="Verdana"/>
-                <a:ea typeface="Verdana"/>
-                <a:cs typeface="Verdana"/>
               </a:defRPr>
             </a:lvl6pPr>
             <a:lvl7pPr>
@@ -4974,9 +4848,6 @@
                     <a:lumOff val="25000"/>
                   </a:schemeClr>
                 </a:solidFill>
-                <a:latin typeface="Verdana"/>
-                <a:ea typeface="Verdana"/>
-                <a:cs typeface="Verdana"/>
               </a:defRPr>
             </a:lvl7pPr>
             <a:lvl8pPr>
@@ -4987,9 +4858,6 @@
                     <a:lumOff val="25000"/>
                   </a:schemeClr>
                 </a:solidFill>
-                <a:latin typeface="Verdana"/>
-                <a:ea typeface="Verdana"/>
-                <a:cs typeface="Verdana"/>
               </a:defRPr>
             </a:lvl8pPr>
             <a:lvl9pPr>
@@ -5000,9 +4868,6 @@
                     <a:lumOff val="25000"/>
                   </a:schemeClr>
                 </a:solidFill>
-                <a:latin typeface="Verdana"/>
-                <a:ea typeface="Verdana"/>
-                <a:cs typeface="Verdana"/>
               </a:defRPr>
             </a:lvl9pPr>
           </a:lstStyle>
@@ -5042,9 +4907,6 @@
                     <a:lumOff val="25000"/>
                   </a:schemeClr>
                 </a:solidFill>
-                <a:latin typeface="Verdana"/>
-                <a:ea typeface="Verdana"/>
-                <a:cs typeface="Verdana"/>
               </a:defRPr>
             </a:lvl1pPr>
             <a:lvl2pPr marL="457200" indent="0" algn="ctr">
@@ -5056,9 +4918,6 @@
                     <a:lumOff val="25000"/>
                   </a:schemeClr>
                 </a:solidFill>
-                <a:latin typeface="Verdana"/>
-                <a:ea typeface="Verdana"/>
-                <a:cs typeface="Verdana"/>
               </a:defRPr>
             </a:lvl2pPr>
             <a:lvl3pPr marL="914400" indent="0" algn="ctr">
@@ -5070,9 +4929,6 @@
                     <a:lumOff val="25000"/>
                   </a:schemeClr>
                 </a:solidFill>
-                <a:latin typeface="Verdana"/>
-                <a:ea typeface="Verdana"/>
-                <a:cs typeface="Verdana"/>
               </a:defRPr>
             </a:lvl3pPr>
             <a:lvl4pPr marL="1371600" indent="0" algn="ctr">
@@ -5084,9 +4940,6 @@
                     <a:lumOff val="25000"/>
                   </a:schemeClr>
                 </a:solidFill>
-                <a:latin typeface="Verdana"/>
-                <a:ea typeface="Verdana"/>
-                <a:cs typeface="Verdana"/>
               </a:defRPr>
             </a:lvl4pPr>
             <a:lvl5pPr marL="1828800" indent="0" algn="ctr">
@@ -5098,9 +4951,6 @@
                     <a:lumOff val="25000"/>
                   </a:schemeClr>
                 </a:solidFill>
-                <a:latin typeface="Verdana"/>
-                <a:ea typeface="Verdana"/>
-                <a:cs typeface="Verdana"/>
               </a:defRPr>
             </a:lvl5pPr>
             <a:lvl6pPr marL="2286000" indent="0" algn="ctr">
@@ -5112,9 +4962,6 @@
                     <a:lumOff val="25000"/>
                   </a:schemeClr>
                 </a:solidFill>
-                <a:latin typeface="Verdana"/>
-                <a:ea typeface="Verdana"/>
-                <a:cs typeface="Verdana"/>
               </a:defRPr>
             </a:lvl6pPr>
             <a:lvl7pPr marL="2743200" indent="0" algn="ctr">
@@ -5126,9 +4973,6 @@
                     <a:lumOff val="25000"/>
                   </a:schemeClr>
                 </a:solidFill>
-                <a:latin typeface="Verdana"/>
-                <a:ea typeface="Verdana"/>
-                <a:cs typeface="Verdana"/>
               </a:defRPr>
             </a:lvl7pPr>
             <a:lvl8pPr marL="3200400" indent="0" algn="ctr">
@@ -5140,9 +4984,6 @@
                     <a:lumOff val="25000"/>
                   </a:schemeClr>
                 </a:solidFill>
-                <a:latin typeface="Verdana"/>
-                <a:ea typeface="Verdana"/>
-                <a:cs typeface="Verdana"/>
               </a:defRPr>
             </a:lvl8pPr>
             <a:lvl9pPr marL="3657600" indent="0" algn="ctr">
@@ -5154,9 +4995,6 @@
                     <a:lumOff val="25000"/>
                   </a:schemeClr>
                 </a:solidFill>
-                <a:latin typeface="Verdana"/>
-                <a:ea typeface="Verdana"/>
-                <a:cs typeface="Verdana"/>
               </a:defRPr>
             </a:lvl9pPr>
           </a:lstStyle>
@@ -5227,14 +5065,14 @@
     </a:clrScheme>
     <a:fontScheme name="Office Theme">
       <a:majorFont>
-        <a:latin typeface="Arial"/>
-        <a:ea typeface="SimSun"/>
-        <a:cs typeface="Arial"/>
+        <a:latin typeface="Verdana"/>
+        <a:ea typeface="Microsoft YaHei"/>
+        <a:cs typeface="Tahoma"/>
       </a:majorFont>
       <a:minorFont>
-        <a:latin typeface="Arial"/>
-        <a:ea typeface="SimSun"/>
-        <a:cs typeface="Arial"/>
+        <a:latin typeface="Verdana"/>
+        <a:ea typeface="Microsoft YaHei"/>
+        <a:cs typeface="Tahoma"/>
       </a:minorFont>
     </a:fontScheme>
     <a:fmtScheme name="Office Theme">
@@ -5464,14 +5302,14 @@
     </a:clrScheme>
     <a:fontScheme name="Arial">
       <a:majorFont>
-        <a:latin typeface="Arial"/>
-        <a:ea typeface="Arial"/>
-        <a:cs typeface="Arial"/>
+        <a:latin typeface="Verdana"/>
+        <a:ea typeface="Microsoft YaHei"/>
+        <a:cs typeface="Tahoma"/>
       </a:majorFont>
       <a:minorFont>
-        <a:latin typeface="Arial"/>
-        <a:ea typeface="Arial"/>
-        <a:cs typeface="Arial"/>
+        <a:latin typeface="Verdana"/>
+        <a:ea typeface="Microsoft YaHei"/>
+        <a:cs typeface="Tahoma"/>
       </a:minorFont>
     </a:fontScheme>
     <a:fmtScheme name="Office">

</xml_diff>